<commit_message>
Restyle frontend with a Synchrony-inspired gold/charcoal palette
Pure presentation-layer change -- no logic, state, or API changes.
Added App.css with CSS custom properties for the palette (warm gold
accent, charcoal text, cream background, based on Synchrony's visible
brand identity -- a close approximation, not claimed pixel-exact official
hex values). Restructured the JSX to use semantic classNames instead of
inline styles: proper card sections, a small bar-mark echoing the
Synchrony logo shape, styled buttons (primary/secondary), risk-band
pills, a highlighted explanation callout, and a fairness stat grid.
Verified visually via a local Vite preview (header, cards, disabled/hover
button states, error banner all rendered correctly) and confirmed the
production build still succeeds before deploying.

Co-Authored-By: Claude Sonnet 5 <noreply@anthropic.com>
</commit_message>
<xml_diff>
--- a/Setu_Synchrony_Hackathon.pptx
+++ b/Setu_Synchrony_Hackathon.pptx
@@ -8832,7 +8832,7 @@
                 <a:ea typeface="Cambria" pitchFamily="34" charset="-122"/>
                 <a:cs typeface="Cambria" pitchFamily="34" charset="-120"/>
               </a:rPr>
-              <a:t>0.89</a:t>
+              <a:t>0.94</a:t>
             </a:r>
             <a:endParaRPr lang="en-US" sz="7200" dirty="0"/>
           </a:p>
@@ -8908,7 +8908,7 @@
         <p:spPr>
           <a:xfrm>
             <a:off x="731520" y="4114800"/>
-            <a:ext cx="4231843" cy="320040"/>
+            <a:ext cx="4469587" cy="320040"/>
           </a:xfrm>
           <a:prstGeom prst="roundRect">
             <a:avLst>
@@ -8977,7 +8977,7 @@
                 <a:ea typeface="Cambria" pitchFamily="34" charset="-122"/>
                 <a:cs typeface="Cambria" pitchFamily="34" charset="-120"/>
               </a:rPr>
-              <a:t>0.96</a:t>
+              <a:t>0.97</a:t>
             </a:r>
             <a:endParaRPr lang="en-US" sz="7200" dirty="0"/>
           </a:p>
@@ -9053,7 +9053,7 @@
         <p:spPr>
           <a:xfrm>
             <a:off x="6309360" y="4114800"/>
-            <a:ext cx="4564685" cy="320040"/>
+            <a:ext cx="4612234" cy="320040"/>
           </a:xfrm>
           <a:prstGeom prst="roundRect">
             <a:avLst>

</xml_diff>

<commit_message>
Fix deck: slides 10/11/13 wrongly claimed persistence/deployment were still planned
Postgres persistence, pgvector cohort search, and the AWS deployment
were all already real and verified -- the deck was stale from an
earlier build checkpoint and undersold the actual finished state.
Corrected the architecture slide, the working-vs-designed scorecard,
and the roadmap to match DESIGN.md's actual status.

Co-Authored-By: Claude Sonnet 5 <noreply@anthropic.com>
</commit_message>
<xml_diff>
--- a/Setu_Synchrony_Hackathon.pptx
+++ b/Setu_Synchrony_Hackathon.pptx
@@ -3233,14 +3233,9 @@
             </a:avLst>
           </a:prstGeom>
           <a:solidFill>
-            <a:srgbClr val="B9D6D3"/>
+            <a:srgbClr val="02C39A"/>
           </a:solidFill>
-          <a:ln w="19050">
-            <a:solidFill>
-              <a:srgbClr val="5B7473"/>
-            </a:solidFill>
-            <a:prstDash val="dash"/>
-          </a:ln>
+          <a:ln/>
         </p:spPr>
       </p:sp>
       <p:sp>
@@ -3270,7 +3265,7 @@
             <a:r>
               <a:rPr lang="en-US" sz="1600" b="1" dirty="0">
                 <a:solidFill>
-                  <a:srgbClr val="16292A"/>
+                  <a:srgbClr val="FFFFFF"/>
                 </a:solidFill>
                 <a:latin typeface="Cambria" pitchFamily="34" charset="0"/>
                 <a:ea typeface="Cambria" pitchFamily="34" charset="-122"/>
@@ -3309,13 +3304,13 @@
             <a:r>
               <a:rPr lang="en-US" sz="1100" dirty="0">
                 <a:solidFill>
-                  <a:srgbClr val="5B7473"/>
-                </a:solidFill>
-                <a:latin typeface="Calibri" pitchFamily="34" charset="0"/>
-                <a:ea typeface="Calibri" pitchFamily="34" charset="-122"/>
-                <a:cs typeface="Calibri" pitchFamily="34" charset="-120"/>
-              </a:rPr>
-              <a:t>Persistence (planned)</a:t>
+                  <a:srgbClr val="E7F5F3"/>
+                </a:solidFill>
+                <a:latin typeface="Calibri" pitchFamily="34" charset="0"/>
+                <a:ea typeface="Calibri" pitchFamily="34" charset="-122"/>
+                <a:cs typeface="Calibri" pitchFamily="34" charset="-120"/>
+              </a:rPr>
+              <a:t>Persistence · cohort search</a:t>
             </a:r>
             <a:endParaRPr lang="en-US" sz="1100" dirty="0"/>
           </a:p>
@@ -3595,8 +3590,8 @@
         </p:nvSpPr>
         <p:spPr>
           <a:xfrm>
-            <a:off x="548640" y="1874520"/>
-            <a:ext cx="329184" cy="329184"/>
+            <a:off x="548640" y="1828800"/>
+            <a:ext cx="292608" cy="292608"/>
           </a:xfrm>
           <a:prstGeom prst="ellipse">
             <a:avLst/>
@@ -3615,8 +3610,8 @@
         </p:nvSpPr>
         <p:spPr>
           <a:xfrm>
-            <a:off x="548640" y="1874520"/>
-            <a:ext cx="329184" cy="329184"/>
+            <a:off x="548640" y="1828800"/>
+            <a:ext cx="292608" cy="292608"/>
           </a:xfrm>
           <a:prstGeom prst="rect">
             <a:avLst/>
@@ -3654,8 +3649,8 @@
         </p:nvSpPr>
         <p:spPr>
           <a:xfrm>
-            <a:off x="1005840" y="1819656"/>
-            <a:ext cx="4663440" cy="457200"/>
+            <a:off x="969264" y="1773936"/>
+            <a:ext cx="4700016" cy="402336"/>
           </a:xfrm>
           <a:prstGeom prst="rect">
             <a:avLst/>
@@ -3671,7 +3666,7 @@
               <a:buNone/>
             </a:pPr>
             <a:r>
-              <a:rPr lang="en-US" sz="1350" dirty="0">
+              <a:rPr lang="en-US" sz="1200" dirty="0">
                 <a:solidFill>
                   <a:srgbClr val="16292A"/>
                 </a:solidFill>
@@ -3681,7 +3676,7 @@
               </a:rPr>
               <a:t>Cohort + blended + direct scoring</a:t>
             </a:r>
-            <a:endParaRPr lang="en-US" sz="1350" dirty="0"/>
+            <a:endParaRPr lang="en-US" sz="1200" dirty="0"/>
           </a:p>
         </p:txBody>
       </p:sp>
@@ -3693,8 +3688,8 @@
         </p:nvSpPr>
         <p:spPr>
           <a:xfrm>
-            <a:off x="548640" y="2441448"/>
-            <a:ext cx="329184" cy="329184"/>
+            <a:off x="548640" y="2249424"/>
+            <a:ext cx="292608" cy="292608"/>
           </a:xfrm>
           <a:prstGeom prst="ellipse">
             <a:avLst/>
@@ -3713,8 +3708,8 @@
         </p:nvSpPr>
         <p:spPr>
           <a:xfrm>
-            <a:off x="548640" y="2441448"/>
-            <a:ext cx="329184" cy="329184"/>
+            <a:off x="548640" y="2249424"/>
+            <a:ext cx="292608" cy="292608"/>
           </a:xfrm>
           <a:prstGeom prst="rect">
             <a:avLst/>
@@ -3752,8 +3747,8 @@
         </p:nvSpPr>
         <p:spPr>
           <a:xfrm>
-            <a:off x="1005840" y="2386584"/>
-            <a:ext cx="4663440" cy="457200"/>
+            <a:off x="969264" y="2194560"/>
+            <a:ext cx="4700016" cy="402336"/>
           </a:xfrm>
           <a:prstGeom prst="rect">
             <a:avLst/>
@@ -3769,7 +3764,7 @@
               <a:buNone/>
             </a:pPr>
             <a:r>
-              <a:rPr lang="en-US" sz="1350" dirty="0">
+              <a:rPr lang="en-US" sz="1200" dirty="0">
                 <a:solidFill>
                   <a:srgbClr val="16292A"/>
                 </a:solidFill>
@@ -3777,9 +3772,9 @@
                 <a:ea typeface="Calibri" pitchFamily="34" charset="-122"/>
                 <a:cs typeface="Calibri" pitchFamily="34" charset="-120"/>
               </a:rPr>
-              <a:t>Explanation generation (template + LLM)</a:t>
-            </a:r>
-            <a:endParaRPr lang="en-US" sz="1350" dirty="0"/>
+              <a:t>Real pgvector cohort search + PCA embeddings</a:t>
+            </a:r>
+            <a:endParaRPr lang="en-US" sz="1200" dirty="0"/>
           </a:p>
         </p:txBody>
       </p:sp>
@@ -3791,8 +3786,8 @@
         </p:nvSpPr>
         <p:spPr>
           <a:xfrm>
-            <a:off x="548640" y="3008376"/>
-            <a:ext cx="329184" cy="329184"/>
+            <a:off x="548640" y="2670048"/>
+            <a:ext cx="292608" cy="292608"/>
           </a:xfrm>
           <a:prstGeom prst="ellipse">
             <a:avLst/>
@@ -3811,8 +3806,8 @@
         </p:nvSpPr>
         <p:spPr>
           <a:xfrm>
-            <a:off x="548640" y="3008376"/>
-            <a:ext cx="329184" cy="329184"/>
+            <a:off x="548640" y="2670048"/>
+            <a:ext cx="292608" cy="292608"/>
           </a:xfrm>
           <a:prstGeom prst="rect">
             <a:avLst/>
@@ -3850,8 +3845,8 @@
         </p:nvSpPr>
         <p:spPr>
           <a:xfrm>
-            <a:off x="1005840" y="2953512"/>
-            <a:ext cx="4663440" cy="457200"/>
+            <a:off x="969264" y="2615184"/>
+            <a:ext cx="4700016" cy="402336"/>
           </a:xfrm>
           <a:prstGeom prst="rect">
             <a:avLst/>
@@ -3867,7 +3862,7 @@
               <a:buNone/>
             </a:pPr>
             <a:r>
-              <a:rPr lang="en-US" sz="1350" dirty="0">
+              <a:rPr lang="en-US" sz="1200" dirty="0">
                 <a:solidFill>
                   <a:srgbClr val="16292A"/>
                 </a:solidFill>
@@ -3875,9 +3870,9 @@
                 <a:ea typeface="Calibri" pitchFamily="34" charset="-122"/>
                 <a:cs typeface="Calibri" pitchFamily="34" charset="-120"/>
               </a:rPr>
-              <a:t>Consent enforcement (server-side)</a:t>
-            </a:r>
-            <a:endParaRPr lang="en-US" sz="1350" dirty="0"/>
+              <a:t>Explanation generation (template + real Groq LLM)</a:t>
+            </a:r>
+            <a:endParaRPr lang="en-US" sz="1200" dirty="0"/>
           </a:p>
         </p:txBody>
       </p:sp>
@@ -3889,8 +3884,8 @@
         </p:nvSpPr>
         <p:spPr>
           <a:xfrm>
-            <a:off x="548640" y="3575304"/>
-            <a:ext cx="329184" cy="329184"/>
+            <a:off x="548640" y="3090672"/>
+            <a:ext cx="292608" cy="292608"/>
           </a:xfrm>
           <a:prstGeom prst="ellipse">
             <a:avLst/>
@@ -3909,8 +3904,8 @@
         </p:nvSpPr>
         <p:spPr>
           <a:xfrm>
-            <a:off x="548640" y="3575304"/>
-            <a:ext cx="329184" cy="329184"/>
+            <a:off x="548640" y="3090672"/>
+            <a:ext cx="292608" cy="292608"/>
           </a:xfrm>
           <a:prstGeom prst="rect">
             <a:avLst/>
@@ -3948,8 +3943,8 @@
         </p:nvSpPr>
         <p:spPr>
           <a:xfrm>
-            <a:off x="1005840" y="3520440"/>
-            <a:ext cx="4663440" cy="457200"/>
+            <a:off x="969264" y="3035808"/>
+            <a:ext cx="4700016" cy="402336"/>
           </a:xfrm>
           <a:prstGeom prst="rect">
             <a:avLst/>
@@ -3965,7 +3960,7 @@
               <a:buNone/>
             </a:pPr>
             <a:r>
-              <a:rPr lang="en-US" sz="1350" dirty="0">
+              <a:rPr lang="en-US" sz="1200" dirty="0">
                 <a:solidFill>
                   <a:srgbClr val="16292A"/>
                 </a:solidFill>
@@ -3973,9 +3968,9 @@
                 <a:ea typeface="Calibri" pitchFamily="34" charset="-122"/>
                 <a:cs typeface="Calibri" pitchFamily="34" charset="-120"/>
               </a:rPr>
-              <a:t>Fairness audit of the trained model</a:t>
-            </a:r>
-            <a:endParaRPr lang="en-US" sz="1350" dirty="0"/>
+              <a:t>Consent enforcement (server-side)</a:t>
+            </a:r>
+            <a:endParaRPr lang="en-US" sz="1200" dirty="0"/>
           </a:p>
         </p:txBody>
       </p:sp>
@@ -3987,8 +3982,8 @@
         </p:nvSpPr>
         <p:spPr>
           <a:xfrm>
-            <a:off x="548640" y="4142232"/>
-            <a:ext cx="329184" cy="329184"/>
+            <a:off x="548640" y="3511296"/>
+            <a:ext cx="292608" cy="292608"/>
           </a:xfrm>
           <a:prstGeom prst="ellipse">
             <a:avLst/>
@@ -4007,8 +4002,8 @@
         </p:nvSpPr>
         <p:spPr>
           <a:xfrm>
-            <a:off x="548640" y="4142232"/>
-            <a:ext cx="329184" cy="329184"/>
+            <a:off x="548640" y="3511296"/>
+            <a:ext cx="292608" cy="292608"/>
           </a:xfrm>
           <a:prstGeom prst="rect">
             <a:avLst/>
@@ -4046,8 +4041,8 @@
         </p:nvSpPr>
         <p:spPr>
           <a:xfrm>
-            <a:off x="1005840" y="4087368"/>
-            <a:ext cx="4663440" cy="457200"/>
+            <a:off x="969264" y="3456432"/>
+            <a:ext cx="4700016" cy="402336"/>
           </a:xfrm>
           <a:prstGeom prst="rect">
             <a:avLst/>
@@ -4063,7 +4058,7 @@
               <a:buNone/>
             </a:pPr>
             <a:r>
-              <a:rPr lang="en-US" sz="1350" dirty="0">
+              <a:rPr lang="en-US" sz="1200" dirty="0">
                 <a:solidFill>
                   <a:srgbClr val="16292A"/>
                 </a:solidFill>
@@ -4071,9 +4066,9 @@
                 <a:ea typeface="Calibri" pitchFamily="34" charset="-122"/>
                 <a:cs typeface="Calibri" pitchFamily="34" charset="-120"/>
               </a:rPr>
-              <a:t>Score history per applicant</a:t>
-            </a:r>
-            <a:endParaRPr lang="en-US" sz="1350" dirty="0"/>
+              <a:t>Fairness audit of the trained model</a:t>
+            </a:r>
+            <a:endParaRPr lang="en-US" sz="1200" dirty="0"/>
           </a:p>
         </p:txBody>
       </p:sp>
@@ -4085,8 +4080,8 @@
         </p:nvSpPr>
         <p:spPr>
           <a:xfrm>
-            <a:off x="548640" y="4709160"/>
-            <a:ext cx="329184" cy="329184"/>
+            <a:off x="548640" y="3931920"/>
+            <a:ext cx="292608" cy="292608"/>
           </a:xfrm>
           <a:prstGeom prst="ellipse">
             <a:avLst/>
@@ -4105,8 +4100,8 @@
         </p:nvSpPr>
         <p:spPr>
           <a:xfrm>
-            <a:off x="548640" y="4709160"/>
-            <a:ext cx="329184" cy="329184"/>
+            <a:off x="548640" y="3931920"/>
+            <a:ext cx="292608" cy="292608"/>
           </a:xfrm>
           <a:prstGeom prst="rect">
             <a:avLst/>
@@ -4144,8 +4139,8 @@
         </p:nvSpPr>
         <p:spPr>
           <a:xfrm>
-            <a:off x="1005840" y="4654296"/>
-            <a:ext cx="4663440" cy="457200"/>
+            <a:off x="969264" y="3877056"/>
+            <a:ext cx="4700016" cy="402336"/>
           </a:xfrm>
           <a:prstGeom prst="rect">
             <a:avLst/>
@@ -4161,7 +4156,7 @@
               <a:buNone/>
             </a:pPr>
             <a:r>
-              <a:rPr lang="en-US" sz="1350" dirty="0">
+              <a:rPr lang="en-US" sz="1200" dirty="0">
                 <a:solidFill>
                   <a:srgbClr val="16292A"/>
                 </a:solidFill>
@@ -4169,15 +4164,211 @@
                 <a:ea typeface="Calibri" pitchFamily="34" charset="-122"/>
                 <a:cs typeface="Calibri" pitchFamily="34" charset="-120"/>
               </a:rPr>
+              <a:t>Score history per applicant (real Postgres)</a:t>
+            </a:r>
+            <a:endParaRPr lang="en-US" sz="1200" dirty="0"/>
+          </a:p>
+        </p:txBody>
+      </p:sp>
+      <p:sp>
+        <p:nvSpPr>
+          <p:cNvPr id="23" name="Shape 21"/>
+          <p:cNvSpPr/>
+          <p:nvPr/>
+        </p:nvSpPr>
+        <p:spPr>
+          <a:xfrm>
+            <a:off x="548640" y="4352544"/>
+            <a:ext cx="292608" cy="292608"/>
+          </a:xfrm>
+          <a:prstGeom prst="ellipse">
+            <a:avLst/>
+          </a:prstGeom>
+          <a:solidFill>
+            <a:srgbClr val="02C39A"/>
+          </a:solidFill>
+          <a:ln/>
+        </p:spPr>
+      </p:sp>
+      <p:sp>
+        <p:nvSpPr>
+          <p:cNvPr id="24" name="Text 22"/>
+          <p:cNvSpPr txBox="1"/>
+          <p:nvPr/>
+        </p:nvSpPr>
+        <p:spPr>
+          <a:xfrm>
+            <a:off x="548640" y="4352544"/>
+            <a:ext cx="292608" cy="292608"/>
+          </a:xfrm>
+          <a:prstGeom prst="rect">
+            <a:avLst/>
+          </a:prstGeom>
+          <a:noFill/>
+          <a:ln/>
+        </p:spPr>
+        <p:txBody>
+          <a:bodyPr wrap="square" lIns="0" tIns="0" rIns="0" bIns="0" rtlCol="0" anchor="ctr"/>
+          <a:lstStyle/>
+          <a:p>
+            <a:pPr algn="ctr" indent="0" marL="0">
+              <a:buNone/>
+            </a:pPr>
+            <a:r>
+              <a:rPr lang="en-US" sz="1800" b="1" dirty="0">
+                <a:solidFill>
+                  <a:srgbClr val="FFFFFF"/>
+                </a:solidFill>
+                <a:latin typeface="Calibri" pitchFamily="34" charset="0"/>
+                <a:ea typeface="Calibri" pitchFamily="34" charset="-122"/>
+                <a:cs typeface="Calibri" pitchFamily="34" charset="-120"/>
+              </a:rPr>
+              <a:t>✓</a:t>
+            </a:r>
+            <a:endParaRPr lang="en-US" sz="1800" dirty="0"/>
+          </a:p>
+        </p:txBody>
+      </p:sp>
+      <p:sp>
+        <p:nvSpPr>
+          <p:cNvPr id="25" name="Text 23"/>
+          <p:cNvSpPr txBox="1"/>
+          <p:nvPr/>
+        </p:nvSpPr>
+        <p:spPr>
+          <a:xfrm>
+            <a:off x="969264" y="4297680"/>
+            <a:ext cx="4700016" cy="402336"/>
+          </a:xfrm>
+          <a:prstGeom prst="rect">
+            <a:avLst/>
+          </a:prstGeom>
+          <a:noFill/>
+          <a:ln/>
+        </p:spPr>
+        <p:txBody>
+          <a:bodyPr wrap="square" lIns="0" tIns="0" rIns="0" bIns="0" rtlCol="0" anchor="ctr"/>
+          <a:lstStyle/>
+          <a:p>
+            <a:pPr indent="0" marL="0">
+              <a:buNone/>
+            </a:pPr>
+            <a:r>
+              <a:rPr lang="en-US" sz="1200" dirty="0">
+                <a:solidFill>
+                  <a:srgbClr val="16292A"/>
+                </a:solidFill>
+                <a:latin typeface="Calibri" pitchFamily="34" charset="0"/>
+                <a:ea typeface="Calibri" pitchFamily="34" charset="-122"/>
+                <a:cs typeface="Calibri" pitchFamily="34" charset="-120"/>
+              </a:rPr>
               <a:t>Right-to-erasure endpoint</a:t>
             </a:r>
-            <a:endParaRPr lang="en-US" sz="1350" dirty="0"/>
-          </a:p>
-        </p:txBody>
-      </p:sp>
-      <p:sp>
-        <p:nvSpPr>
-          <p:cNvPr id="23" name="Shape 21"/>
+            <a:endParaRPr lang="en-US" sz="1200" dirty="0"/>
+          </a:p>
+        </p:txBody>
+      </p:sp>
+      <p:sp>
+        <p:nvSpPr>
+          <p:cNvPr id="26" name="Shape 24"/>
+          <p:cNvSpPr/>
+          <p:nvPr/>
+        </p:nvSpPr>
+        <p:spPr>
+          <a:xfrm>
+            <a:off x="548640" y="4773168"/>
+            <a:ext cx="292608" cy="292608"/>
+          </a:xfrm>
+          <a:prstGeom prst="ellipse">
+            <a:avLst/>
+          </a:prstGeom>
+          <a:solidFill>
+            <a:srgbClr val="02C39A"/>
+          </a:solidFill>
+          <a:ln/>
+        </p:spPr>
+      </p:sp>
+      <p:sp>
+        <p:nvSpPr>
+          <p:cNvPr id="27" name="Text 25"/>
+          <p:cNvSpPr txBox="1"/>
+          <p:nvPr/>
+        </p:nvSpPr>
+        <p:spPr>
+          <a:xfrm>
+            <a:off x="548640" y="4773168"/>
+            <a:ext cx="292608" cy="292608"/>
+          </a:xfrm>
+          <a:prstGeom prst="rect">
+            <a:avLst/>
+          </a:prstGeom>
+          <a:noFill/>
+          <a:ln/>
+        </p:spPr>
+        <p:txBody>
+          <a:bodyPr wrap="square" lIns="0" tIns="0" rIns="0" bIns="0" rtlCol="0" anchor="ctr"/>
+          <a:lstStyle/>
+          <a:p>
+            <a:pPr algn="ctr" indent="0" marL="0">
+              <a:buNone/>
+            </a:pPr>
+            <a:r>
+              <a:rPr lang="en-US" sz="1800" b="1" dirty="0">
+                <a:solidFill>
+                  <a:srgbClr val="FFFFFF"/>
+                </a:solidFill>
+                <a:latin typeface="Calibri" pitchFamily="34" charset="0"/>
+                <a:ea typeface="Calibri" pitchFamily="34" charset="-122"/>
+                <a:cs typeface="Calibri" pitchFamily="34" charset="-120"/>
+              </a:rPr>
+              <a:t>✓</a:t>
+            </a:r>
+            <a:endParaRPr lang="en-US" sz="1800" dirty="0"/>
+          </a:p>
+        </p:txBody>
+      </p:sp>
+      <p:sp>
+        <p:nvSpPr>
+          <p:cNvPr id="28" name="Text 26"/>
+          <p:cNvSpPr txBox="1"/>
+          <p:nvPr/>
+        </p:nvSpPr>
+        <p:spPr>
+          <a:xfrm>
+            <a:off x="969264" y="4718304"/>
+            <a:ext cx="4700016" cy="402336"/>
+          </a:xfrm>
+          <a:prstGeom prst="rect">
+            <a:avLst/>
+          </a:prstGeom>
+          <a:noFill/>
+          <a:ln/>
+        </p:spPr>
+        <p:txBody>
+          <a:bodyPr wrap="square" lIns="0" tIns="0" rIns="0" bIns="0" rtlCol="0" anchor="ctr"/>
+          <a:lstStyle/>
+          <a:p>
+            <a:pPr indent="0" marL="0">
+              <a:buNone/>
+            </a:pPr>
+            <a:r>
+              <a:rPr lang="en-US" sz="1200" dirty="0">
+                <a:solidFill>
+                  <a:srgbClr val="16292A"/>
+                </a:solidFill>
+                <a:latin typeface="Calibri" pitchFamily="34" charset="0"/>
+                <a:ea typeface="Calibri" pitchFamily="34" charset="-122"/>
+                <a:cs typeface="Calibri" pitchFamily="34" charset="-120"/>
+              </a:rPr>
+              <a:t>Live on AWS (Docker Compose, 4 containers)</a:t>
+            </a:r>
+            <a:endParaRPr lang="en-US" sz="1200" dirty="0"/>
+          </a:p>
+        </p:txBody>
+      </p:sp>
+      <p:sp>
+        <p:nvSpPr>
+          <p:cNvPr id="29" name="Shape 27"/>
           <p:cNvSpPr/>
           <p:nvPr/>
         </p:nvSpPr>
@@ -4197,7 +4388,7 @@
       </p:sp>
       <p:sp>
         <p:nvSpPr>
-          <p:cNvPr id="24" name="Text 22"/>
+          <p:cNvPr id="30" name="Text 28"/>
           <p:cNvSpPr txBox="1"/>
           <p:nvPr/>
         </p:nvSpPr>
@@ -4228,7 +4419,7 @@
                 <a:ea typeface="Calibri" pitchFamily="34" charset="-122"/>
                 <a:cs typeface="Calibri" pitchFamily="34" charset="-120"/>
               </a:rPr>
-              <a:t>Postgres persistence (schema ready)</a:t>
+              <a:t>Human-in-the-loop review queue for borderline scores</a:t>
             </a:r>
             <a:endParaRPr lang="en-US" sz="1350" dirty="0"/>
           </a:p>
@@ -4236,7 +4427,7 @@
       </p:sp>
       <p:sp>
         <p:nvSpPr>
-          <p:cNvPr id="25" name="Shape 23"/>
+          <p:cNvPr id="31" name="Shape 29"/>
           <p:cNvSpPr/>
           <p:nvPr/>
         </p:nvSpPr>
@@ -4256,7 +4447,7 @@
       </p:sp>
       <p:sp>
         <p:nvSpPr>
-          <p:cNvPr id="26" name="Text 24"/>
+          <p:cNvPr id="32" name="Text 30"/>
           <p:cNvSpPr txBox="1"/>
           <p:nvPr/>
         </p:nvSpPr>
@@ -4287,7 +4478,7 @@
                 <a:ea typeface="Calibri" pitchFamily="34" charset="-122"/>
                 <a:cs typeface="Calibri" pitchFamily="34" charset="-120"/>
               </a:rPr>
-              <a:t>Human-in-the-loop review queue</a:t>
+              <a:t>Production-grade SHAP explainability</a:t>
             </a:r>
             <a:endParaRPr lang="en-US" sz="1350" dirty="0"/>
           </a:p>
@@ -4295,7 +4486,7 @@
       </p:sp>
       <p:sp>
         <p:nvSpPr>
-          <p:cNvPr id="27" name="Shape 25"/>
+          <p:cNvPr id="33" name="Shape 31"/>
           <p:cNvSpPr/>
           <p:nvPr/>
         </p:nvSpPr>
@@ -4315,7 +4506,7 @@
       </p:sp>
       <p:sp>
         <p:nvSpPr>
-          <p:cNvPr id="28" name="Text 26"/>
+          <p:cNvPr id="34" name="Text 32"/>
           <p:cNvSpPr txBox="1"/>
           <p:nvPr/>
         </p:nvSpPr>
@@ -4346,7 +4537,7 @@
                 <a:ea typeface="Calibri" pitchFamily="34" charset="-122"/>
                 <a:cs typeface="Calibri" pitchFamily="34" charset="-120"/>
               </a:rPr>
-              <a:t>Production-grade SHAP explainability</a:t>
+              <a:t>IAM / secrets-manager-based access control</a:t>
             </a:r>
             <a:endParaRPr lang="en-US" sz="1350" dirty="0"/>
           </a:p>
@@ -4354,7 +4545,7 @@
       </p:sp>
       <p:sp>
         <p:nvSpPr>
-          <p:cNvPr id="29" name="Shape 27"/>
+          <p:cNvPr id="35" name="Shape 33"/>
           <p:cNvSpPr/>
           <p:nvPr/>
         </p:nvSpPr>
@@ -4374,7 +4565,7 @@
       </p:sp>
       <p:sp>
         <p:nvSpPr>
-          <p:cNvPr id="30" name="Text 28"/>
+          <p:cNvPr id="36" name="Text 34"/>
           <p:cNvSpPr txBox="1"/>
           <p:nvPr/>
         </p:nvSpPr>
@@ -4405,7 +4596,7 @@
                 <a:ea typeface="Calibri" pitchFamily="34" charset="-122"/>
                 <a:cs typeface="Calibri" pitchFamily="34" charset="-120"/>
               </a:rPr>
-              <a:t>Real AWS Bedrock + cloud deployment</a:t>
+              <a:t>Structured monitoring &amp; logging</a:t>
             </a:r>
             <a:endParaRPr lang="en-US" sz="1350" dirty="0"/>
           </a:p>
@@ -4413,7 +4604,7 @@
       </p:sp>
       <p:sp>
         <p:nvSpPr>
-          <p:cNvPr id="31" name="Shape 29"/>
+          <p:cNvPr id="37" name="Shape 35"/>
           <p:cNvSpPr/>
           <p:nvPr/>
         </p:nvSpPr>
@@ -4435,7 +4626,7 @@
       </p:sp>
       <p:sp>
         <p:nvSpPr>
-          <p:cNvPr id="32" name="Text 30"/>
+          <p:cNvPr id="38" name="Text 36"/>
           <p:cNvSpPr txBox="1"/>
           <p:nvPr/>
         </p:nvSpPr>
@@ -4474,7 +4665,7 @@
       </p:sp>
       <p:sp>
         <p:nvSpPr>
-          <p:cNvPr id="33" name="Text 31"/>
+          <p:cNvPr id="39" name="Text 37"/>
           <p:cNvSpPr txBox="1"/>
           <p:nvPr/>
         </p:nvSpPr>
@@ -4513,7 +4704,7 @@
       </p:sp>
       <p:sp>
         <p:nvSpPr>
-          <p:cNvPr id="34" name="Text 32"/>
+          <p:cNvPr id="40" name="Text 38"/>
           <p:cNvSpPr txBox="1"/>
           <p:nvPr/>
         </p:nvSpPr>
@@ -5155,7 +5346,7 @@
                 <a:ea typeface="Calibri" pitchFamily="34" charset="-122"/>
                 <a:cs typeface="Calibri" pitchFamily="34" charset="-120"/>
               </a:rPr>
-              <a:t>Wire real Postgres persistence — schema already defined in db/init.sql</a:t>
+              <a:t>Human-in-the-loop review queue for borderline scores</a:t>
             </a:r>
             <a:endParaRPr lang="en-US" sz="1550" dirty="0"/>
           </a:p>
@@ -5253,7 +5444,7 @@
                 <a:ea typeface="Calibri" pitchFamily="34" charset="-122"/>
                 <a:cs typeface="Calibri" pitchFamily="34" charset="-120"/>
               </a:rPr>
-              <a:t>Human-in-the-loop review queue for borderline scores</a:t>
+              <a:t>Production-grade SHAP explainability in place of the permutation approximation</a:t>
             </a:r>
             <a:endParaRPr lang="en-US" sz="1550" dirty="0"/>
           </a:p>
@@ -5351,7 +5542,7 @@
                 <a:ea typeface="Calibri" pitchFamily="34" charset="-122"/>
                 <a:cs typeface="Calibri" pitchFamily="34" charset="-120"/>
               </a:rPr>
-              <a:t>Production-grade SHAP explainability in place of the permutation approximation</a:t>
+              <a:t>IAM / secrets-manager-based access control (currently environment-variable hygiene)</a:t>
             </a:r>
             <a:endParaRPr lang="en-US" sz="1550" dirty="0"/>
           </a:p>
@@ -5449,7 +5640,7 @@
                 <a:ea typeface="Calibri" pitchFamily="34" charset="-122"/>
                 <a:cs typeface="Calibri" pitchFamily="34" charset="-120"/>
               </a:rPr>
-              <a:t>Real AWS Bedrock integration and cloud deployment</a:t>
+              <a:t>Structured monitoring and logging (currently default framework logs)</a:t>
             </a:r>
             <a:endParaRPr lang="en-US" sz="1550" dirty="0"/>
           </a:p>

</xml_diff>